<commit_message>
docs: doi ten de tai "go khong dau" thanh "go thieu dau"
Tu khi bo cong dinh tuyen, he xu ly ca cau go dau mot nua, nen ten cu
hep hon pham vi that. Chi doi o cac dong mang ten de tai; cac cho mo ta
buoc 7 van giu "khong dau" vi dung nghia. Dung lai slide.
</commit_message>
<xml_diff>
--- a/docs/slides/Nhom09_XLNNTN_BaoCao.pptx
+++ b/docs/slides/Nhom09_XLNNTN_BaoCao.pptx
@@ -519,7 +519,7 @@
             <a:r>
               <a:rPr lang="en-US" dirty="0"/>
               <a:t>MỞ ĐẦU. Nói chậm, nhìn thầy. Khoảng 20 giây.
-"Em xin chào thầy và các bạn. Nhóm 09 báo cáo đề tài Truy hồi điều luật tiếng Việt cho câu hỏi gõ không dấu."
+"Em xin chào thầy và các bạn. Nhóm 09 báo cáo đề tài Truy hồi điều luật tiếng Việt cho câu hỏi gõ thiếu dấu."
 Nếu cần nói đề tài bằng một câu: "Mô hình ngữ nghĩa sạch tốt nhất tụt từ 97 xuống 12 phần trăm khi người dân gõ không dấu. Nhóm đo điều đó cho sạch, rồi sửa nó bằng một mô hình ngôn ngữ nhỏ học từ chính kho luật."
 Đừng đọc lại tên từng thành viên, thầy đã có danh sách. Chuyển slide ngay.</a:t>
             </a:r>
@@ -2642,7 +2642,7 @@
                 <a:ea typeface="Arial" pitchFamily="34" charset="-122"/>
                 <a:cs typeface="Arial" pitchFamily="34" charset="-120"/>
               </a:rPr>
-              <a:t>cho câu hỏi gõ không dấu</a:t>
+              <a:t>cho câu hỏi gõ thiếu dấu</a:t>
             </a:r>
             <a:endParaRPr lang="en-US" sz="2600" dirty="0"/>
           </a:p>

</xml_diff>

<commit_message>
docs: chot ten de tai "Tim kiem dieu luat tieng Viet cho cau hoi go thieu dau"
Giu chu "Tim kiem dieu luat" cua ten da dang ky, dua phan it nguoi lam
(cau go thieu dau, ro ri du lieu o ca mo hinh tien huan luyen) len ten,
phan ket hop tu khoa va ngu nghia vao phan mo ta trong ngoac. Slide bia
dung ban ngan. Dung lai slide.
</commit_message>
<xml_diff>
--- a/docs/slides/Nhom09_XLNNTN_BaoCao.pptx
+++ b/docs/slides/Nhom09_XLNNTN_BaoCao.pptx
@@ -519,7 +519,7 @@
             <a:r>
               <a:rPr lang="en-US" dirty="0"/>
               <a:t>MỞ ĐẦU. Nói chậm, nhìn thầy. Khoảng 20 giây.
-"Em xin chào thầy và các bạn. Nhóm 09 báo cáo đề tài Truy hồi điều luật tiếng Việt cho câu hỏi gõ thiếu dấu."
+"Em xin chào thầy và các bạn. Nhóm 09 báo cáo đề tài Tìm kiếm điều luật tiếng Việt cho câu hỏi gõ thiếu dấu."
 Nếu cần nói đề tài bằng một câu: "Mô hình ngữ nghĩa sạch tốt nhất tụt từ 97 xuống 12 phần trăm khi người dân gõ không dấu. Nhóm đo điều đó cho sạch, rồi sửa nó bằng một mô hình ngôn ngữ nhỏ học từ chính kho luật."
 Đừng đọc lại tên từng thành viên, thầy đã có danh sách. Chuyển slide ngay.</a:t>
             </a:r>
@@ -2622,7 +2622,7 @@
                 <a:ea typeface="Arial" pitchFamily="34" charset="-122"/>
                 <a:cs typeface="Arial" pitchFamily="34" charset="-120"/>
               </a:rPr>
-              <a:t>Truy hồi điều luật tiếng Việt</a:t>
+              <a:t>Tìm kiếm điều luật tiếng Việt</a:t>
             </a:r>
             <a:endParaRPr lang="en-US" sz="2600" dirty="0"/>
           </a:p>
@@ -2681,7 +2681,7 @@
                 <a:ea typeface="Arial" pitchFamily="34" charset="-122"/>
                 <a:cs typeface="Arial" pitchFamily="34" charset="-120"/>
               </a:rPr>
-              <a:t>Phục hồi dấu, truy hồi lai và kiểm toán rò rỉ dữ liệu</a:t>
+              <a:t>Kết hợp từ khóa và ngữ nghĩa, phục hồi dấu, kiểm toán rò rỉ dữ liệu</a:t>
             </a:r>
             <a:endParaRPr lang="en-US" sz="1500" dirty="0"/>
           </a:p>

</xml_diff>

<commit_message>
slides: loi thoai 15 slide cho khoang 10 phut, phan vai ba nguoi
Loi thoai tach ra loi_thoai.js, so lieu van doc tu reports/. build.js dem am tiet de uoc thoi gian tung slide va bao slide nao lech qua 8 giay.
</commit_message>
<xml_diff>
--- a/docs/slides/Nhom09_XLNNTN_BaoCao.pptx
+++ b/docs/slides/Nhom09_XLNNTN_BaoCao.pptx
@@ -3193,8 +3193,8 @@
           <a:p>
             <a:r>
               <a:rPr lang="en-US" dirty="0"/>
-              <a:t>BÌA. Khoảng 15 giây.
-"Em xin chào thầy và các bạn. Nhóm 09 báo cáo đề tài Tìm kiếm điều luật tiếng Việt cho câu hỏi gõ thiếu dấu."</a:t>
+              <a:t>Lê Hoàng Lộc  ·  khoảng 15 giây
+Em chào thầy và các bạn. Nhóm 09 gồm Lộc, Tuấn Anh và Thư. Đề tài của nhóm là tìm kiếm điều luật tiếng Việt cho câu hỏi gõ thiếu dấu.</a:t>
             </a:r>
             <a:endParaRPr lang="en-US" dirty="0"/>
           </a:p>
@@ -3282,12 +3282,13 @@
           <a:p>
             <a:r>
               <a:rPr lang="en-US" dirty="0"/>
-              <a:t>Khoảng 45 giây. Trả lời câu hỏi nghiên cứu 1.
-"788 câu test, chấm một lần. BM25 được 85,22, ngữ nghĩa 97,21, hợp nhất có trọng số 97,72 phần trăm."
-"Hợp nhất hơn ngữ nghĩa 0,51 điểm, tính theo số câu là 4 câu trên 788. Có cải thiện nhưng rất nhỏ, mỗi cấu hình một seed nên nhóm không gọi đó là đáng kể."
-"RRF chỉ nhìn thứ hạng nên còn kém ngữ nghĩa ở Recall@1, khớp với Bruch và cộng sự 2023."
-Nếu thầy hỏi về bkai: Recall@10 97,46 nhưng đã học tập test, nên không đưa vào so sánh.
-Nếu thầy hỏi F2 sao thấp: cố định k bằng 10 nên precision tối đa 0,1, không so với bảng xếp hạng Zalo được.</a:t>
+              <a:t>Lê Thị Tuấn Anh  ·  khoảng 45 giây
+Đến câu hỏi thứ nhất. Trên 788 câu test có dấu, Recall@10 của BM25 là 85,22, ngữ nghĩa 97,21, hợp nhất 97,72 phần trăm.
+Hợp nhất hơn ngữ nghĩa 0,51 điểm, đếm ra chỉ 4 câu. Có cải thiện nhưng rất nhỏ, và mỗi cấu hình nhóm chỉ chạy một lần nên không dám nói là đáng kể. Cách RRF chỉ dựa vào thứ hạng còn kém ngữ nghĩa ở Recall@1. Em xin chuyển cho bạn Thư.
+Nếu thầy hỏi: bkai điểm cao hơn, sao không dùng?
+bkai đạt 97,46 nhưng đã học tập test, như slide 7, nên không so với các hệ sạch.
+Nếu thầy hỏi: F2 sao thấp?
+Nhóm cố định lấy 10 kết quả nên precision cao nhất chỉ 0,1. Zalo cho trả về số kết quả tùy ý, nên không so với bảng xếp hạng được.</a:t>
             </a:r>
             <a:endParaRPr lang="en-US" dirty="0"/>
           </a:p>
@@ -3375,11 +3376,11 @@
           <a:p>
             <a:r>
               <a:rPr lang="en-US" dirty="0"/>
-              <a:t>Khoảng 40 giây.
-"Đối chiếu chéo ở top-10: 669 câu cả hai tầng đều đúng, 98 câu chỉ ngữ nghĩa đúng, và chỉ 3 câu mà BM25 đúng còn ngữ nghĩa sai. Đó là toàn bộ khoảng trống hợp nhất có thể lấp."
-"Vậy có bỏ BM25 không? Không, vì hai lý do khác điểm số: nhanh hơn khoảng 700 lần, và chỉ ra được đúng những từ đã khớp. Với tra cứu luật, người dùng sắp viện dẫn điều đó nên cần biết vì sao nó được chọn."
-"Và ở phần sau, khi mất dấu, BM25 là tầng đứng vững nhất."
-Nếu thầy hỏi 18 câu cả hai sai: nhóm đọc tay 17 ca hệ lai sai, 10 ca thiếu ngữ cảnh pháp lý như câu nướng bắp, 2 ca nhãn gold đáng ngờ.</a:t>
+              <a:t>Đoàn Mậu Thiên Thư  ·  khoảng 40 giây
+Dạ. Vì sao hợp nhất giúp ít như vậy? Đối chiếu từng câu thì 669 câu cả hai nhánh đều tìm đúng, 98 câu chỉ ngữ nghĩa đúng, còn BM25 đúng mà ngữ nghĩa sai thì chỉ có 3 câu.
+Vậy có bỏ BM25 không? Nhóm vẫn giữ, vì nó nhanh hơn khoảng 700 lần, chỉ mục nhỏ hơn gần mười lần, và chỉ ra được từ nào đã khớp để người dùng kiểm lại. Ở phần sau BM25 còn có vai trò khác.
+Nếu thầy hỏi: Hệ vẫn sai ở những câu nào?
+Hệ hợp nhất sai 17 câu, nhóm đọc tay cả 17: 10 ca thiếu ngữ cảnh pháp lý như câu nướng bắp, 5 ca nhiều điều cùng đúng mà nhãn ghi một, 2 ca nhãn đáng ngờ.</a:t>
             </a:r>
             <a:endParaRPr lang="en-US" dirty="0"/>
           </a:p>
@@ -3467,12 +3468,13 @@
           <a:p>
             <a:r>
               <a:rPr lang="en-US" dirty="0"/>
-              <a:t>Khoảng 45 giây. Kết quả chính của đồ án, nói chậm.
-"Nhóm lấy đúng 788 câu test, bỏ hết dấu bằng máy, giữ nguyên nhãn, rồi chạy lại đúng hệ vừa rồi."
-Chỉ cột đỏ: "Ngữ nghĩa tụt từ 97,21 xuống 12,44. BM25 và hợp nhất cũng vậy. Cả hệ gần như không dùng được."
-"Riêng BM25, nếu lập chỉ mục trên văn bản đã bỏ dấu thì lên lại 74,30, không cần mô hình nào. Nhưng cách tốt nhất là phục hồi dấu, slide sau."
-Nếu thầy hỏi vì sao ngữ nghĩa sụp: giả thuyết là mô hình học chủ yếu văn bản có dấu, chưa kiểm chứng trực tiếp.
-Nếu thầy hỏi BM25 bỏ dấu giảm do bỏ dấu hay do đổi cách tách từ: đo trên val, đổi cách tách từ mất 0,047, bỏ dấu mất thêm 0,137.</a:t>
+              <a:t>Đoàn Mậu Thiên Thư  ·  khoảng 45 giây
+Câu hỏi thứ hai. Nhóm lấy đúng 788 câu test đó, bỏ hết dấu bằng máy, giữ nguyên nhãn rồi chạy lại. Mô hình ngữ nghĩa từ 97,21 rơi xuống 12,44. BM25 còn 6,22, hợp nhất cũng chỉ 14,47. Gần như không dùng được.
+BM25 hỏng vì phat và phạt không khớp nhau. Còn mô hình ngữ nghĩa, nhóm đoán là do nó học chủ yếu văn bản có dấu, cái này chưa kiểm chứng. Lập chỉ mục BM25 trên văn bản bỏ dấu thì lên lại 74,30, nhưng vẫn còn xa.
+Nếu thầy hỏi: Câu không dấu do máy tạo, có giống người gõ thật không?
+Chưa giống hẳn: người thật còn gõ tắt, sai chính tả. Nhóm chọn cách này vì giữ nguyên được nhãn nên đo sạch. Đây là giới hạn lớn nhất.
+Nếu thầy hỏi: BM25 bỏ dấu giảm là do bỏ dấu hay do đổi cách tách từ?
+Cả hai. Đo riêng trên val: đổi cách tách từ mất 0,047, bỏ dấu mất thêm 0,137.</a:t>
             </a:r>
             <a:endParaRPr lang="en-US" dirty="0"/>
           </a:p>
@@ -3560,10 +3562,11 @@
           <a:p>
             <a:r>
               <a:rPr lang="en-US" dirty="0"/>
-              <a:t>Khoảng 45 giây. Trả lời câu hỏi nghiên cứu 2.
-"Cách làm đơn giản: đếm các cặp âm tiết liền nhau trên 18,6 triệu âm tiết của chính kho luật và câu hỏi train. Mỗi âm tiết không dấu có nhiều dạng có dấu, ví dụ nghi có thể là nghỉ, nghị, nghĩ. Viterbi chọn chuỗi có xác suất cao nhất."
-"98,45 phần trăm âm tiết đúng, 0,88 mili giây mỗi câu, học xong trong 15 giây, không cần GPU. Hệ từ 14,47 lên 96,70, chỉ kém câu có dấu 1,02 điểm."
-Nếu thầy hỏi sao không dùng mô hình phục hồi dấu có sẵn: chưa so trên cùng bộ dữ liệu nên không nói hơn kém; bigram có lợi là không phải tải thêm mô hình.</a:t>
+              <a:t>Đoàn Mậu Thiên Thư  ·  khoảng 45 giây
+Cách nhóm sửa là phục hồi dấu trước khi tìm. Nhóm đếm các cặp âm tiết đi liền nhau trong 18,6 triệu âm tiết của chính kho luật. Mỗi âm tiết không dấu có vài ứng viên, như nghi có thể là nghỉ, nghị, nghĩ, rồi thuật toán Viterbi chọn chuỗi có xác suất cao nhất.
+Kết quả đúng 98,45 phần trăm âm tiết, mỗi câu chưa tới một mili giây, học xong trong 15 giây trên CPU. Hệ từ 14,47 lên 96,70, chỉ kém câu có dấu 1,02 điểm.
+Nếu thầy hỏi: Sao không dùng mô hình phục hồi dấu có sẵn hoặc LLM?
+Nhóm chưa so trên cùng bộ dữ liệu nên không nói hơn kém. Bigram có lợi là không phải tải thêm mô hình, chạy trên CPU, và học đúng từ vựng luật.</a:t>
             </a:r>
             <a:endParaRPr lang="en-US" dirty="0"/>
           </a:p>
@@ -3651,10 +3654,9 @@
           <a:p>
             <a:r>
               <a:rPr lang="en-US" dirty="0"/>
-              <a:t>Khoảng 35 giây.
-Trái: "Chỗ sai rơi vào từ nói thường mà văn bản luật không dùng: tài xế thành tải xe, máu thành mẫu. Chính là khoảng cách từ vựng ở slide 2. 166 câu sai ít nhất một âm tiết; ở nhóm này mất 9 câu đúng, được 1."
-Phải: "Vì âm tiết đã có dấu được giữ nguyên, câu gõ dấu một nửa cũng được sửa: từ 74,81 lên 97,21. Câu vốn đủ dấu vẫn giữ 97,72, vì 769 trên 788 câu không bị đổi chữ nào. Nên không cần hỏi câu có dấu hay chưa."
-Câu nửa dấu cũng do máy tạo: mỗi âm tiết bị bỏ dấu với xác suất một nửa.</a:t>
+              <a:t>Đoàn Mậu Thiên Thư  ·  khoảng 35 giây
+Phục hồi vẫn sai, chủ yếu ở từ nói thường mà luật không dùng, như tài xế thành tải xe, máu thành mẫu. Có 166 câu sai ít nhất một âm tiết, trong đó mất 9 câu tìm đúng và được lại 1 câu.
+Bên phải là câu gõ dấu một nửa, chữ có dấu chữ không. Vì chữ đã có dấu được giữ nguyên nên câu nửa dấu từ 74,81 lên 97,21, còn câu đủ dấu cho qua vẫn giữ 97,72.</a:t>
             </a:r>
             <a:endParaRPr lang="en-US" dirty="0"/>
           </a:p>
@@ -3742,11 +3744,9 @@
           <a:p>
             <a:r>
               <a:rPr lang="en-US" dirty="0"/>
-              <a:t>Khoảng 35 giây. Nói chậm, đây là ấn tượng cuối.
-"Một: câu có dấu, hợp nhất chỉ hơn ngữ nghĩa 0,51 điểm, tức 4 câu. BM25 đáng giữ vì nhanh và giải thích được."
-"Hai, điều nhóm muốn thầy nhớ: mất dấu thì hệ chỉ còn 14,47 phần trăm, và một mô hình bigram nhỏ học từ chính kho luật kéo về 96,70."
-"Ba: chống rò rỉ không dừng ở chia lại tập, mô hình tải về cũng có thể đã thấy tập test."
-"Em xin hết phần trình bày, nhóm xin demo code."</a:t>
+              <a:t>Đoàn Mậu Thiên Thư  ·  khoảng 35 giây
+Nhóm rút ra ba điều. Một, với câu có dấu, hợp nhất chỉ hơn ngữ nghĩa 4 câu, BM25 đáng giữ vì nhanh và giải thích được. Hai, khi mất dấu thì hệ sụp, và một mô hình bigram nhỏ học từ kho luật kéo lại gần hết. Ba, chống rò rỉ phải kiểm cả mô hình tải về, không dừng ở chia lại tập.
+Giới hạn lớn nhất là câu không dấu do máy tạo, chưa có câu người thật gõ. Em xin hết phần trình bày, nhóm xin chuyển sang demo.</a:t>
             </a:r>
             <a:endParaRPr lang="en-US" dirty="0"/>
           </a:p>
@@ -3834,7 +3834,7 @@
           <a:p>
             <a:r>
               <a:rPr lang="en-US" dirty="0"/>
-              <a:t>Không trình bày. Danh sách đọc thẳng từ docs/NGHIEN_CUU_LIEN_QUAN.md.</a:t>
+              <a:t>Không trình bày.</a:t>
             </a:r>
             <a:endParaRPr lang="en-US" dirty="0"/>
           </a:p>
@@ -3922,9 +3922,10 @@
           <a:p>
             <a:r>
               <a:rPr lang="en-US" dirty="0"/>
-              <a:t>Khoảng 40 giây.
-Ý chính: hai khoảng cách giữa câu hỏi và điều luật. Thẻ trái: không trùng từ nào. Thẻ phải: mất dấu thì "phạt" và "phat" là hai chữ khác nhau với máy.
-Chốt: "Đầu vào là một câu hỏi, đầu ra là danh sách điều luật xếp hạng trong 61.425 điều."</a:t>
+              <a:t>Lê Hoàng Lộc  ·  khoảng 40 giây
+Bài toán là: người dân gõ một câu hỏi pháp luật, hệ thống trả về điều luật liên quan trong 61.425 điều của 3.271 văn bản.
+Khó ở hai chỗ. Một là người hỏi dùng lời thường còn luật dùng thuật ngữ, như câu nướng bắp trên cầu này, điều luật đúng không trùng với câu hỏi chữ nào.
+Hai, cũng là chỗ nhóm tập trung, là nhiều người gõ không dấu, nhất là khi nhắn trên điện thoại. Với máy thì chữ phạt có dấu và chữ phat không dấu là hai chữ khác hẳn nhau.</a:t>
             </a:r>
             <a:endParaRPr lang="en-US" dirty="0"/>
           </a:p>
@@ -4012,10 +4013,11 @@
           <a:p>
             <a:r>
               <a:rPr lang="en-US" dirty="0"/>
-              <a:t>Khoảng 40 giây. Không đọc hết bảng, chỉ đọc cột phải.
-Dòng 1: từ Zalo 2021 tới EACL 2026 đều ghép BM25 với ngữ nghĩa và đều thấy ghép tốt hơn. Lặp lại phép so đó thì không có gì mới.
-Dòng 4, nói chậm: phục hồi dấu tiếng Việt đạt khoảng 97% nhưng được đo như bài toán riêng, chưa ai đo ảnh hưởng lên tìm luật.
-Nếu thầy hỏi "đọc hết chưa": đối chiếu theo phần tóm tắt, mã nguồn và model card, danh sách ở slide 16.</a:t>
+              <a:t>Lê Hoàng Lộc  ·  khoảng 40 giây
+Nhóm có đọc lại các nghiên cứu trước. Ghép tìm theo từ khóa với tìm theo ngữ nghĩa thì từ các đội thi Zalo 2021 đến bài ở hội nghị EACL năm nay đều làm rồi, và đều thấy ghép tốt hơn dùng riêng. Nhóm chỉ lặp lại phép so đó thì không có gì mới.
+Dòng màu đỏ mới là chỗ nhóm để ý: phục hồi dấu tiếng Việt đã đạt khoảng 97 phần trăm, nhưng người ta đo nó như một bài toán riêng, chưa ai đo xem nó giúp tìm luật được bao nhiêu.
+Nếu thầy hỏi: Nhóm đọc hết các bài đó chưa?
+Nhóm đọc phần tóm tắt, mã nguồn và model card, không đọc hết toàn văn. Danh sách 27 nguồn ở slide 16.</a:t>
             </a:r>
             <a:endParaRPr lang="en-US" dirty="0"/>
           </a:p>
@@ -4103,10 +4105,11 @@
           <a:p>
             <a:r>
               <a:rPr lang="en-US" dirty="0"/>
-              <a:t>Khoảng 40 giây. Chỉ tay vào ô đỏ.
-"Tìm luật thì chỉ chấm trên câu có dấu. Phục hồi dấu thì chỉ đo độ chính xác âm tiết. Ô giao nhau, tìm luật trên câu mất dấu, chưa ai đo. Đó là câu hỏi nghiên cứu 2."
-"Câu hỏi 1 là điều kiện của câu hỏi 2: muốn biết mất dấu làm hỏng bao nhiêu thì cần một mốc có dấu đo sạch trước."
-Nếu thầy hỏi "chắc chưa ai làm": chỉ khẳng định trong các nguồn nhóm đã đối chiếu.</a:t>
+              <a:t>Lê Hoàng Lộc  ·  khoảng 40 giây
+Xếp lại thì ra cái bảng này. Tìm luật trên câu có dấu thì làm nhiều rồi, phục hồi dấu cũng làm rồi. Còn ô đỏ, tìm luật khi câu hỏi mất dấu, thì trong các nguồn nhóm đọc chưa ai đo. Đó là câu hỏi thứ hai.
+Câu hỏi thứ nhất là để có một mốc sạch: trên câu có dấu, với dữ liệu đã kiểm tra và mô hình chưa thấy dữ liệu, ghép thêm BM25 được bao nhiêu. Có mốc đó rồi mới đo được mất dấu làm hỏng bao nhiêu.
+Nếu thầy hỏi: Chắc chắn chưa ai làm?
+Nhóm chỉ nói trong phạm vi các nguồn đã đối chiếu, không dám khẳng định cho mọi công trình.</a:t>
             </a:r>
             <a:endParaRPr lang="en-US" dirty="0"/>
           </a:p>
@@ -4194,11 +4197,11 @@
           <a:p>
             <a:r>
               <a:rPr lang="en-US" dirty="0"/>
-              <a:t>Khoảng 40 giây.
-"Bộ Zalo AI 2021, bản BEIR trên HuggingFace, đã vào MTEB. Nhóm vẫn kiểm toán lại từ đầu, mỗi phát hiện có một tệp bằng chứng trong reports/audit."
-Chỉ thanh cuối: "26 câu hỏi nằm ở cả train lẫn test. Slide sau."
-Chỉ thanh thứ ba: "4 văn bản bị tách đôi chỉ vì nd và nđ. Chuyện dấu đã gây lỗi ngay trong dữ liệu gốc."
-Nếu thầy hỏi sao không xóa điều trùng: kho luật thật có điều trùng thật, xóa đi làm bài dễ đi giả tạo.</a:t>
+              <a:t>Lê Hoàng Lộc  ·  khoảng 40 giây
+Dữ liệu là bộ Zalo AI Challenge 2021, bản trên HuggingFace, đã được đưa vào bộ đánh giá MTEB. Bộ gốc chỉ có train và test, không có tập val, nên nhóm tự cắt val ra từ train.
+Bộ này đã công bố nhưng nhóm vẫn kiểm tra lại, ra sáu vấn đề như biểu đồ. Có 780 điều bị nhân đôi chỉ vì mã văn bản viết nd hay nđ, tức là chuyện dấu đã gây lỗi ngay trong dữ liệu. Nặng nhất là thanh cuối: 26 câu hỏi nằm ở cả train lẫn test. Phần này bạn Tuấn Anh nói tiếp.
+Nếu thầy hỏi: Sao không xóa các điều trùng?
+Kho luật thật có điều trùng thật, và các nhóm trùng đều nằm ở những văn bản khác nhau. Xóa đi thì bài toán dễ đi một cách giả tạo, nên nhóm chỉ báo cáo.</a:t>
             </a:r>
             <a:endParaRPr lang="en-US" dirty="0"/>
           </a:p>
@@ -4286,10 +4289,12 @@
           <a:p>
             <a:r>
               <a:rPr lang="en-US" dirty="0"/>
-              <a:t>Khoảng 45 giây. Điểm nhấn của phần kiểm toán.
-"Trong 26 câu chồng lấn, 24 câu trùng đúng mã. Chúng không phải dòng lặp: cả 24 câu, tệp train chỉ sang một điều luật, tệp test chỉ sang điều khác."
-Đọc dòng đầu bảng.
-Chốt: "Bộ nhãn không đầy đủ, nên mọi Recall trong báo cáo là cận dưới. Nhóm bỏ dòng train của các câu này, giữ nguyên test của ban tổ chức."</a:t>
+              <a:t>Lê Thị Tuấn Anh  ·  khoảng 45 giây
+Dạ, trong 26 câu đó có 24 câu trùng đúng mã câu hỏi. Tưởng là dòng bị lặp, nhưng đọc kỹ thì cả 24 câu đều mang nhãn khác nhau: tệp train chỉ sang một điều luật, tệp test chỉ sang điều khác.
+Như câu đầu, bị thương tật 25 phần trăm có bị khởi tố không, train ghi luật sửa đổi Bộ luật Hình sự, test ghi Bộ luật Tố tụng Hình sự. Điều nào cũng liên quan. Tức là một câu hỏi có thể đúng với nhiều điều mà nhãn chỉ ghi một, nên mọi con số Recall nhóm báo cáo đều là cận dưới.
+Nhóm bỏ nhãn train của các câu này và giữ nguyên tập test của ban tổ chức.
+Nếu thầy hỏi: Sao không gộp nhãn train vào test cho đủ?
+Gộp vào là tự sửa nhãn của tập test bằng phỏng đoán của nhóm. Bản chạy đầu có gộp nhầm, test phình từ 793 lên 818 cặp, nhóm phát hiện khi đối chiếu số dòng với tệp gốc và đã sửa.</a:t>
             </a:r>
             <a:endParaRPr lang="en-US" dirty="0"/>
           </a:p>
@@ -4377,10 +4382,11 @@
           <a:p>
             <a:r>
               <a:rPr lang="en-US" dirty="0"/>
-              <a:t>Khoảng 45 giây. Phát hiện đáng giá nhất, nói chậm.
-"Chống rò rỉ thường dừng ở chia lại tập. Nhưng mô hình tiền huấn luyện mình tải về cũng có thể đã thấy tập test. Nhóm đọc model card của bkai, mô hình bi-encoder tiếng Việt phổ biến nhất: nó học 80% tập train Zalo 2021, mà tập test của nhóm cắt ra từ đúng tập đó."
-"Giống xem đề và đáp án trước khi thi. Nhóm chuyển sang AITeamVN, model card ghi không học bộ này, làm mô hình sạch cho mọi con số chính thức. bkai vẫn báo cáo nhưng gắn nhãn nhiễm bẩn."
-Nếu thầy hỏi sao tin model card: không kiểm chứng trực tiếp được, nhóm ghi rõ đó là tuyên bố của tác giả mô hình.</a:t>
+              <a:t>Lê Thị Tuấn Anh  ·  khoảng 45 giây
+Rò rỉ còn nằm ở chỗ khó thấy hơn, là trong mô hình. Nhóm định dùng bkai, mô hình nhúng tiếng Việt được dùng nhiều nhất. Nhưng model card của họ ghi đã huấn luyện trên 80 phần trăm tập train của Zalo 2021, mà tập test của nhóm lại cắt ra từ đúng tập đó. Tức là mô hình đã xem đề và đáp án trước khi thi.
+Nên nhóm chuyển sang AITeamVN, model card ghi rõ không học bộ này, và dùng nó cho mọi con số chính thức. bkai vẫn chạy để so nhưng gắn nhãn nhiễm bẩn. Chia lại xong, nhóm có 1.925 câu train, 481 câu val để chỉnh tham số, và 788 câu test chỉ chạy đúng một lần.
+Nếu thầy hỏi: Sao tin model card của AITeamVN?
+Nhóm không kiểm chứng trực tiếp được, nên ghi rõ đó là lời của tác giả mô hình, không phải kết quả nhóm tự đo.</a:t>
             </a:r>
             <a:endParaRPr lang="en-US" dirty="0"/>
           </a:p>
@@ -4468,11 +4474,12 @@
           <a:p>
             <a:r>
               <a:rPr lang="en-US" dirty="0"/>
-              <a:t>Khoảng 45 giây. Đi theo mũi tên từ trái sang phải.
-"Mọi câu hỏi đều qua khâu phục hồi dấu trước, không cần hỏi câu có dấu hay chưa: âm tiết đã có dấu giữ nguyên, chỉ phần thiếu được sửa."
-"Rồi câu hỏi vào hai nhánh song song: BM25 trên 61.425 điều đã tách từ bằng pyvi, và bi-encoder trên 154.176 đoạn, gộp về điều bằng điểm cao nhất. Mỗi nhánh trả top-100, tầng hợp nhất cộng điểm theo trọng số."
-"Đầu ra trích nguyên văn khoản luật, không sinh chữ, nên không bịa được."
-Nếu thầy hỏi vì sao gộp max: đo trên val, max 0,9563, mean 0,9127.</a:t>
+              <a:t>Lê Thị Tuấn Anh  ·  khoảng 45 giây
+Đây là kiến trúc. Câu hỏi nào cũng đi qua khâu phục hồi dấu trước, không cần biết nó có dấu hay chưa, vì chữ đã có dấu thì giữ nguyên.
+Sau đó chia hai nhánh. Nhánh trên là BM25, tách từ bằng pyvi rồi tìm trên nguyên điều luật, mạnh ở số hiệu và thuật ngữ. Nhánh dưới là mô hình ngữ nghĩa, tìm trên các đoạn nhỏ rồi lấy điểm cao nhất của mỗi điều. Mỗi nhánh lấy 100 kết quả rồi cộng điểm theo trọng số, alpha 0,75 chọn trên val.
+Đầu ra trích nguyên văn khoản luật chứ không sinh câu trả lời, nên không bịa ra được.
+Nếu thầy hỏi: Sao lấy điểm cao nhất mà không lấy trung bình các đoạn?
+Câu trả lời thường nằm gọn trong một khoản, lấy trung bình thì các khoản khác kéo điểm xuống. Đo trên val: max 0,9563, trung bình 0,9127.</a:t>
             </a:r>
             <a:endParaRPr lang="en-US" dirty="0"/>
           </a:p>
@@ -4560,10 +4567,9 @@
           <a:p>
             <a:r>
               <a:rPr lang="en-US" dirty="0"/>
-              <a:t>Khoảng 35 giây.
-"Mô hình nhận tối đa 256 token, khoảng 140 từ. Phần đỏ là các điều dài hơn thế: 61,1 phần trăm. Cắt cụt là vứt phần đuôi, mà đuôi điều luật hay là mức phạt và ngoại lệ."
-"Nhóm cắt theo ranh giới khoản, khoản nào quá dài mới trượt cửa sổ, mỗi đoạn mang tiêu đề điều. Kết quả 61.425 điều thành 154.176 đoạn."
-Nếu thầy hỏi sao không dùng mô hình ngữ cảnh dài: để hai bộ mã hóa ăn cùng một bộ đoạn, biến duy nhất là bộ mã hóa.</a:t>
+              <a:t>Lê Thị Tuấn Anh  ·  khoảng 35 giây
+Vì sao phải chia đoạn? Mô hình chỉ đọc được 256 token, khoảng 140 chữ. Phần màu đỏ là các điều dài hơn thế, chiếm 61,1 phần trăm. Cắt cụt thì mất phần đuôi, mà đuôi điều luật hay là mức phạt và các ngoại lệ.
+Nhóm cắt theo từng khoản, khoản nào quá dài mới cắt tiếp, đoạn nào cũng gắn tiêu đề điều ở đầu. 61.425 điều thành 154.176 đoạn.</a:t>
             </a:r>
             <a:endParaRPr lang="en-US" dirty="0"/>
           </a:p>

</xml_diff>